<commit_message>
Refactor InstanceEdit caching logic to update cache with the latest InstanceEdit for a person
</commit_message>
<xml_diff>
--- a/docs/DiagramWorkflow.pptx
+++ b/docs/DiagramWorkflow.pptx
@@ -107,6 +107,11 @@
       </a:defRPr>
     </a:lvl9pPr>
   </p:defaultTextStyle>
+  <p:extLst>
+    <p:ext uri="{EFAFB233-063F-42B5-8137-9DF3F51BA10A}">
+      <p15:sldGuideLst xmlns:p15="http://schemas.microsoft.com/office/powerpoint/2012/main"/>
+    </p:ext>
+  </p:extLst>
 </p:presentation>
 </file>
 
@@ -192,7 +197,7 @@
           <a:p>
             <a:fld id="{1FE8835D-683B-1C42-BD9B-08F9E6A845AC}" type="datetimeFigureOut">
               <a:rPr lang="en-US" smtClean="0"/>
-              <a:t>10/28/25</a:t>
+              <a:t>5/18/26</a:t>
             </a:fld>
             <a:endParaRPr lang="en-US"/>
           </a:p>
@@ -690,7 +695,7 @@
           <a:p>
             <a:fld id="{72FFF423-C1EC-6549-8A1B-EF176AB498F6}" type="datetimeFigureOut">
               <a:rPr lang="en-US" smtClean="0"/>
-              <a:t>10/28/25</a:t>
+              <a:t>5/18/26</a:t>
             </a:fld>
             <a:endParaRPr lang="en-US"/>
           </a:p>
@@ -888,7 +893,7 @@
           <a:p>
             <a:fld id="{72FFF423-C1EC-6549-8A1B-EF176AB498F6}" type="datetimeFigureOut">
               <a:rPr lang="en-US" smtClean="0"/>
-              <a:t>10/28/25</a:t>
+              <a:t>5/18/26</a:t>
             </a:fld>
             <a:endParaRPr lang="en-US"/>
           </a:p>
@@ -1096,7 +1101,7 @@
           <a:p>
             <a:fld id="{72FFF423-C1EC-6549-8A1B-EF176AB498F6}" type="datetimeFigureOut">
               <a:rPr lang="en-US" smtClean="0"/>
-              <a:t>10/28/25</a:t>
+              <a:t>5/18/26</a:t>
             </a:fld>
             <a:endParaRPr lang="en-US"/>
           </a:p>
@@ -1294,7 +1299,7 @@
           <a:p>
             <a:fld id="{72FFF423-C1EC-6549-8A1B-EF176AB498F6}" type="datetimeFigureOut">
               <a:rPr lang="en-US" smtClean="0"/>
-              <a:t>10/28/25</a:t>
+              <a:t>5/18/26</a:t>
             </a:fld>
             <a:endParaRPr lang="en-US"/>
           </a:p>
@@ -1569,7 +1574,7 @@
           <a:p>
             <a:fld id="{72FFF423-C1EC-6549-8A1B-EF176AB498F6}" type="datetimeFigureOut">
               <a:rPr lang="en-US" smtClean="0"/>
-              <a:t>10/28/25</a:t>
+              <a:t>5/18/26</a:t>
             </a:fld>
             <a:endParaRPr lang="en-US"/>
           </a:p>
@@ -1834,7 +1839,7 @@
           <a:p>
             <a:fld id="{72FFF423-C1EC-6549-8A1B-EF176AB498F6}" type="datetimeFigureOut">
               <a:rPr lang="en-US" smtClean="0"/>
-              <a:t>10/28/25</a:t>
+              <a:t>5/18/26</a:t>
             </a:fld>
             <a:endParaRPr lang="en-US"/>
           </a:p>
@@ -2246,7 +2251,7 @@
           <a:p>
             <a:fld id="{72FFF423-C1EC-6549-8A1B-EF176AB498F6}" type="datetimeFigureOut">
               <a:rPr lang="en-US" smtClean="0"/>
-              <a:t>10/28/25</a:t>
+              <a:t>5/18/26</a:t>
             </a:fld>
             <a:endParaRPr lang="en-US"/>
           </a:p>
@@ -2387,7 +2392,7 @@
           <a:p>
             <a:fld id="{72FFF423-C1EC-6549-8A1B-EF176AB498F6}" type="datetimeFigureOut">
               <a:rPr lang="en-US" smtClean="0"/>
-              <a:t>10/28/25</a:t>
+              <a:t>5/18/26</a:t>
             </a:fld>
             <a:endParaRPr lang="en-US"/>
           </a:p>
@@ -2500,7 +2505,7 @@
           <a:p>
             <a:fld id="{72FFF423-C1EC-6549-8A1B-EF176AB498F6}" type="datetimeFigureOut">
               <a:rPr lang="en-US" smtClean="0"/>
-              <a:t>10/28/25</a:t>
+              <a:t>5/18/26</a:t>
             </a:fld>
             <a:endParaRPr lang="en-US"/>
           </a:p>
@@ -2811,7 +2816,7 @@
           <a:p>
             <a:fld id="{72FFF423-C1EC-6549-8A1B-EF176AB498F6}" type="datetimeFigureOut">
               <a:rPr lang="en-US" smtClean="0"/>
-              <a:t>10/28/25</a:t>
+              <a:t>5/18/26</a:t>
             </a:fld>
             <a:endParaRPr lang="en-US"/>
           </a:p>
@@ -3099,7 +3104,7 @@
           <a:p>
             <a:fld id="{72FFF423-C1EC-6549-8A1B-EF176AB498F6}" type="datetimeFigureOut">
               <a:rPr lang="en-US" smtClean="0"/>
-              <a:t>10/28/25</a:t>
+              <a:t>5/18/26</a:t>
             </a:fld>
             <a:endParaRPr lang="en-US"/>
           </a:p>
@@ -3340,7 +3345,7 @@
           <a:p>
             <a:fld id="{72FFF423-C1EC-6549-8A1B-EF176AB498F6}" type="datetimeFigureOut">
               <a:rPr lang="en-US" smtClean="0"/>
-              <a:t>10/28/25</a:t>
+              <a:t>5/18/26</a:t>
             </a:fld>
             <a:endParaRPr lang="en-US"/>
           </a:p>
@@ -3771,7 +3776,7 @@
         </p:nvSpPr>
         <p:spPr>
           <a:xfrm>
-            <a:off x="5462335" y="3818020"/>
+            <a:off x="5211324" y="2697432"/>
             <a:ext cx="1371600" cy="368968"/>
           </a:xfrm>
           <a:prstGeom prst="roundRect">
@@ -3824,7 +3829,7 @@
         </p:nvSpPr>
         <p:spPr>
           <a:xfrm>
-            <a:off x="1620252" y="3156285"/>
+            <a:off x="1369241" y="2035697"/>
             <a:ext cx="1371600" cy="368968"/>
           </a:xfrm>
           <a:prstGeom prst="roundRect">
@@ -3877,7 +3882,7 @@
         </p:nvSpPr>
         <p:spPr>
           <a:xfrm>
-            <a:off x="4331368" y="2241884"/>
+            <a:off x="4080357" y="1121296"/>
             <a:ext cx="1371600" cy="368968"/>
           </a:xfrm>
           <a:prstGeom prst="roundRect">
@@ -3926,7 +3931,7 @@
         </p:nvSpPr>
         <p:spPr>
           <a:xfrm>
-            <a:off x="9577135" y="3252538"/>
+            <a:off x="9326124" y="2131950"/>
             <a:ext cx="1371600" cy="368968"/>
           </a:xfrm>
           <a:prstGeom prst="roundRect">
@@ -3979,7 +3984,7 @@
         </p:nvSpPr>
         <p:spPr>
           <a:xfrm>
-            <a:off x="6833935" y="2241884"/>
+            <a:off x="6582924" y="1121296"/>
             <a:ext cx="1371600" cy="368968"/>
           </a:xfrm>
           <a:prstGeom prst="roundRect">
@@ -4039,7 +4044,7 @@
         </p:nvCxnSpPr>
         <p:spPr>
           <a:xfrm>
-            <a:off x="2991852" y="3340769"/>
+            <a:off x="2740841" y="2220181"/>
             <a:ext cx="2470483" cy="661735"/>
           </a:xfrm>
           <a:prstGeom prst="bentConnector3">
@@ -4083,7 +4088,7 @@
         </p:nvCxnSpPr>
         <p:spPr>
           <a:xfrm flipV="1">
-            <a:off x="2991852" y="2426368"/>
+            <a:off x="2740841" y="1305780"/>
             <a:ext cx="1339516" cy="914401"/>
           </a:xfrm>
           <a:prstGeom prst="bentConnector3">
@@ -4127,7 +4132,7 @@
         </p:nvCxnSpPr>
         <p:spPr>
           <a:xfrm flipV="1">
-            <a:off x="6833935" y="3621506"/>
+            <a:off x="6582924" y="2500918"/>
             <a:ext cx="3429000" cy="380998"/>
           </a:xfrm>
           <a:prstGeom prst="bentConnector2">
@@ -4166,7 +4171,7 @@
         </p:nvSpPr>
         <p:spPr>
           <a:xfrm>
-            <a:off x="10245366" y="3713474"/>
+            <a:off x="9994355" y="2592886"/>
             <a:ext cx="439544" cy="276999"/>
           </a:xfrm>
           <a:prstGeom prst="rect">
@@ -4204,7 +4209,7 @@
         </p:nvCxnSpPr>
         <p:spPr>
           <a:xfrm rot="16200000" flipH="1">
-            <a:off x="7134724" y="124328"/>
+            <a:off x="6883713" y="-996260"/>
             <a:ext cx="1010654" cy="5245767"/>
           </a:xfrm>
           <a:prstGeom prst="bentConnector3">
@@ -4245,7 +4250,7 @@
         </p:nvSpPr>
         <p:spPr>
           <a:xfrm>
-            <a:off x="10245366" y="2931423"/>
+            <a:off x="9994355" y="1810835"/>
             <a:ext cx="482696" cy="276999"/>
           </a:xfrm>
           <a:prstGeom prst="rect">
@@ -4284,7 +4289,7 @@
         </p:nvCxnSpPr>
         <p:spPr>
           <a:xfrm>
-            <a:off x="8205535" y="2426368"/>
+            <a:off x="7954524" y="1305780"/>
             <a:ext cx="2057400" cy="826170"/>
           </a:xfrm>
           <a:prstGeom prst="bentConnector2">
@@ -4323,7 +4328,7 @@
         </p:nvSpPr>
         <p:spPr>
           <a:xfrm>
-            <a:off x="8660807" y="2190220"/>
+            <a:off x="8409796" y="1069632"/>
             <a:ext cx="1371600" cy="461665"/>
           </a:xfrm>
           <a:prstGeom prst="rect">
@@ -4378,7 +4383,7 @@
         </p:nvCxnSpPr>
         <p:spPr>
           <a:xfrm rot="10800000" flipV="1">
-            <a:off x="6148135" y="3437022"/>
+            <a:off x="5897124" y="2316434"/>
             <a:ext cx="3429000" cy="380998"/>
           </a:xfrm>
           <a:prstGeom prst="bentConnector2">
@@ -4417,7 +4422,7 @@
         </p:nvSpPr>
         <p:spPr>
           <a:xfrm>
-            <a:off x="8943325" y="3156285"/>
+            <a:off x="8692314" y="2035697"/>
             <a:ext cx="651140" cy="276999"/>
           </a:xfrm>
           <a:prstGeom prst="rect">
@@ -4455,7 +4460,7 @@
         </p:nvCxnSpPr>
         <p:spPr>
           <a:xfrm flipV="1">
-            <a:off x="6148134" y="2610852"/>
+            <a:off x="5897123" y="1490264"/>
             <a:ext cx="1371601" cy="822159"/>
           </a:xfrm>
           <a:prstGeom prst="bentConnector2">
@@ -4494,7 +4499,7 @@
         </p:nvSpPr>
         <p:spPr>
           <a:xfrm>
-            <a:off x="3082314" y="3083823"/>
+            <a:off x="2831303" y="1963235"/>
             <a:ext cx="625492" cy="276999"/>
           </a:xfrm>
           <a:prstGeom prst="rect">
@@ -4529,7 +4534,7 @@
         </p:nvSpPr>
         <p:spPr>
           <a:xfrm>
-            <a:off x="3707806" y="1727518"/>
+            <a:off x="3456795" y="606930"/>
             <a:ext cx="4922847" cy="2719137"/>
           </a:xfrm>
           <a:prstGeom prst="rect">
@@ -4580,7 +4585,7 @@
         </p:nvSpPr>
         <p:spPr>
           <a:xfrm>
-            <a:off x="8630653" y="1724526"/>
+            <a:off x="8379642" y="603938"/>
             <a:ext cx="2470483" cy="2719137"/>
           </a:xfrm>
           <a:prstGeom prst="rect">
@@ -4631,7 +4636,7 @@
         </p:nvSpPr>
         <p:spPr>
           <a:xfrm>
-            <a:off x="1454973" y="1724526"/>
+            <a:off x="1203962" y="603938"/>
             <a:ext cx="2249810" cy="2719137"/>
           </a:xfrm>
           <a:prstGeom prst="rect">
@@ -4682,7 +4687,7 @@
         </p:nvSpPr>
         <p:spPr>
           <a:xfrm>
-            <a:off x="5139844" y="4459800"/>
+            <a:off x="4888833" y="3339212"/>
             <a:ext cx="2058769" cy="369332"/>
           </a:xfrm>
           <a:prstGeom prst="rect">
@@ -4725,7 +4730,7 @@
         </p:nvSpPr>
         <p:spPr>
           <a:xfrm>
-            <a:off x="8905534" y="4459800"/>
+            <a:off x="8654523" y="3339212"/>
             <a:ext cx="1920719" cy="369332"/>
           </a:xfrm>
           <a:prstGeom prst="rect">
@@ -4760,7 +4765,7 @@
         </p:nvSpPr>
         <p:spPr>
           <a:xfrm>
-            <a:off x="1886355" y="4465934"/>
+            <a:off x="1635344" y="3345346"/>
             <a:ext cx="1387046" cy="369332"/>
           </a:xfrm>
           <a:prstGeom prst="rect">
@@ -4795,7 +4800,7 @@
         </p:nvSpPr>
         <p:spPr>
           <a:xfrm>
-            <a:off x="6096000" y="2987388"/>
+            <a:off x="5844989" y="1866800"/>
             <a:ext cx="1339517" cy="461665"/>
           </a:xfrm>
           <a:prstGeom prst="rect">
@@ -4827,6 +4832,107 @@
               <a:t>json</a:t>
             </a:r>
             <a:endParaRPr lang="en-US" sz="1200" dirty="0"/>
+          </a:p>
+        </p:txBody>
+      </p:sp>
+      <p:sp>
+        <p:nvSpPr>
+          <p:cNvPr id="2" name="TextBox 1">
+            <a:extLst>
+              <a:ext uri="{FF2B5EF4-FFF2-40B4-BE49-F238E27FC236}">
+                <a16:creationId xmlns:a16="http://schemas.microsoft.com/office/drawing/2014/main" id="{6A1A71FF-5764-B141-C505-B2C8E40E2282}"/>
+              </a:ext>
+            </a:extLst>
+          </p:cNvPr>
+          <p:cNvSpPr txBox="1"/>
+          <p:nvPr/>
+        </p:nvSpPr>
+        <p:spPr>
+          <a:xfrm>
+            <a:off x="1168435" y="4259376"/>
+            <a:ext cx="9406807" cy="1477328"/>
+          </a:xfrm>
+          <a:prstGeom prst="rect">
+            <a:avLst/>
+          </a:prstGeom>
+          <a:noFill/>
+        </p:spPr>
+        <p:txBody>
+          <a:bodyPr wrap="square" rtlCol="0">
+            <a:spAutoFit/>
+          </a:bodyPr>
+          <a:lstStyle/>
+          <a:p>
+            <a:r>
+              <a:rPr lang="en-US" dirty="0" err="1"/>
+              <a:t>Cytoscape.json</a:t>
+            </a:r>
+            <a:r>
+              <a:rPr lang="en-US" dirty="0"/>
+              <a:t> is used for </a:t>
+            </a:r>
+            <a:r>
+              <a:rPr lang="en-US" dirty="0" err="1"/>
+              <a:t>PathwayDiagram</a:t>
+            </a:r>
+            <a:r>
+              <a:rPr lang="en-US" dirty="0"/>
+              <a:t> instances only, which are for editing.</a:t>
+            </a:r>
+          </a:p>
+          <a:p>
+            <a:r>
+              <a:rPr lang="en-US" dirty="0"/>
+              <a:t>Pathways should have their diagram </a:t>
+            </a:r>
+            <a:r>
+              <a:rPr lang="en-US" dirty="0" err="1"/>
+              <a:t>json</a:t>
+            </a:r>
+            <a:r>
+              <a:rPr lang="en-US" dirty="0"/>
+              <a:t> text. If edited, they are converted from </a:t>
+            </a:r>
+            <a:r>
+              <a:rPr lang="en-US" dirty="0" err="1"/>
+              <a:t>PathwayDiagram</a:t>
+            </a:r>
+            <a:r>
+              <a:rPr lang="en-US" dirty="0"/>
+              <a:t> </a:t>
+            </a:r>
+            <a:r>
+              <a:rPr lang="en-US" dirty="0" err="1"/>
+              <a:t>cytoscape.json</a:t>
+            </a:r>
+            <a:r>
+              <a:rPr lang="en-US" dirty="0"/>
+              <a:t>. Otherwise, they are originally converted from </a:t>
+            </a:r>
+            <a:r>
+              <a:rPr lang="en-US" dirty="0" err="1"/>
+              <a:t>XML@gk_central</a:t>
+            </a:r>
+            <a:r>
+              <a:rPr lang="en-US" dirty="0"/>
+              <a:t>. Each </a:t>
+            </a:r>
+            <a:r>
+              <a:rPr lang="en-US" dirty="0" err="1"/>
+              <a:t>PathwayDiagram</a:t>
+            </a:r>
+            <a:r>
+              <a:rPr lang="en-US" dirty="0"/>
+              <a:t> should have its own diagram JSON converted directly from </a:t>
+            </a:r>
+            <a:r>
+              <a:rPr lang="en-US" dirty="0" err="1"/>
+              <a:t>XML@gk_central</a:t>
+            </a:r>
+            <a:r>
+              <a:rPr lang="en-US" dirty="0"/>
+              <a:t> too, which are used for editing from scratch. </a:t>
+            </a:r>
           </a:p>
         </p:txBody>
       </p:sp>

</xml_diff>